<commit_message>
Updates and correction to graudate project slides
</commit_message>
<xml_diff>
--- a/SupplementaryMaterials/GraduateIndependentProject.pptx
+++ b/SupplementaryMaterials/GraduateIndependentProject.pptx
@@ -8,9 +8,9 @@
     <p:sldId id="718" r:id="rId2"/>
     <p:sldId id="267" r:id="rId3"/>
     <p:sldId id="298" r:id="rId4"/>
-    <p:sldId id="299" r:id="rId5"/>
-    <p:sldId id="300" r:id="rId6"/>
-    <p:sldId id="379" r:id="rId7"/>
+    <p:sldId id="379" r:id="rId5"/>
+    <p:sldId id="299" r:id="rId6"/>
+    <p:sldId id="300" r:id="rId7"/>
   </p:sldIdLst>
   <p:sldSz cx="12192000" cy="6858000"/>
   <p:notesSz cx="6858000" cy="9144000"/>
@@ -109,6 +109,11 @@
       </a:defRPr>
     </a:lvl9pPr>
   </p:defaultTextStyle>
+  <p:extLst>
+    <p:ext uri="{EFAFB233-063F-42B5-8137-9DF3F51BA10A}">
+      <p15:sldGuideLst xmlns:p15="http://schemas.microsoft.com/office/powerpoint/2012/main"/>
+    </p:ext>
+  </p:extLst>
 </p:presentation>
 </file>
 
@@ -259,7 +264,7 @@
           <a:p>
             <a:fld id="{41EA29B2-5B60-4524-9406-F439795E8972}" type="datetimeFigureOut">
               <a:rPr lang="en-US" smtClean="0"/>
-              <a:t>7/8/2025</a:t>
+              <a:t>9/28/2026</a:t>
             </a:fld>
             <a:endParaRPr lang="en-US"/>
           </a:p>
@@ -457,7 +462,7 @@
           <a:p>
             <a:fld id="{41EA29B2-5B60-4524-9406-F439795E8972}" type="datetimeFigureOut">
               <a:rPr lang="en-US" smtClean="0"/>
-              <a:t>7/8/2025</a:t>
+              <a:t>9/28/2026</a:t>
             </a:fld>
             <a:endParaRPr lang="en-US"/>
           </a:p>
@@ -665,7 +670,7 @@
           <a:p>
             <a:fld id="{41EA29B2-5B60-4524-9406-F439795E8972}" type="datetimeFigureOut">
               <a:rPr lang="en-US" smtClean="0"/>
-              <a:t>7/8/2025</a:t>
+              <a:t>9/28/2026</a:t>
             </a:fld>
             <a:endParaRPr lang="en-US"/>
           </a:p>
@@ -863,7 +868,7 @@
           <a:p>
             <a:fld id="{41EA29B2-5B60-4524-9406-F439795E8972}" type="datetimeFigureOut">
               <a:rPr lang="en-US" smtClean="0"/>
-              <a:t>7/8/2025</a:t>
+              <a:t>9/28/2026</a:t>
             </a:fld>
             <a:endParaRPr lang="en-US"/>
           </a:p>
@@ -1138,7 +1143,7 @@
           <a:p>
             <a:fld id="{41EA29B2-5B60-4524-9406-F439795E8972}" type="datetimeFigureOut">
               <a:rPr lang="en-US" smtClean="0"/>
-              <a:t>7/8/2025</a:t>
+              <a:t>9/28/2026</a:t>
             </a:fld>
             <a:endParaRPr lang="en-US"/>
           </a:p>
@@ -1403,7 +1408,7 @@
           <a:p>
             <a:fld id="{41EA29B2-5B60-4524-9406-F439795E8972}" type="datetimeFigureOut">
               <a:rPr lang="en-US" smtClean="0"/>
-              <a:t>7/8/2025</a:t>
+              <a:t>9/28/2026</a:t>
             </a:fld>
             <a:endParaRPr lang="en-US"/>
           </a:p>
@@ -1815,7 +1820,7 @@
           <a:p>
             <a:fld id="{41EA29B2-5B60-4524-9406-F439795E8972}" type="datetimeFigureOut">
               <a:rPr lang="en-US" smtClean="0"/>
-              <a:t>7/8/2025</a:t>
+              <a:t>9/28/2026</a:t>
             </a:fld>
             <a:endParaRPr lang="en-US"/>
           </a:p>
@@ -1956,7 +1961,7 @@
           <a:p>
             <a:fld id="{41EA29B2-5B60-4524-9406-F439795E8972}" type="datetimeFigureOut">
               <a:rPr lang="en-US" smtClean="0"/>
-              <a:t>7/8/2025</a:t>
+              <a:t>9/28/2026</a:t>
             </a:fld>
             <a:endParaRPr lang="en-US"/>
           </a:p>
@@ -2069,7 +2074,7 @@
           <a:p>
             <a:fld id="{41EA29B2-5B60-4524-9406-F439795E8972}" type="datetimeFigureOut">
               <a:rPr lang="en-US" smtClean="0"/>
-              <a:t>7/8/2025</a:t>
+              <a:t>9/28/2026</a:t>
             </a:fld>
             <a:endParaRPr lang="en-US"/>
           </a:p>
@@ -2380,7 +2385,7 @@
           <a:p>
             <a:fld id="{41EA29B2-5B60-4524-9406-F439795E8972}" type="datetimeFigureOut">
               <a:rPr lang="en-US" smtClean="0"/>
-              <a:t>7/8/2025</a:t>
+              <a:t>9/28/2026</a:t>
             </a:fld>
             <a:endParaRPr lang="en-US"/>
           </a:p>
@@ -2668,7 +2673,7 @@
           <a:p>
             <a:fld id="{41EA29B2-5B60-4524-9406-F439795E8972}" type="datetimeFigureOut">
               <a:rPr lang="en-US" smtClean="0"/>
-              <a:t>7/8/2025</a:t>
+              <a:t>9/28/2026</a:t>
             </a:fld>
             <a:endParaRPr lang="en-US"/>
           </a:p>
@@ -2909,7 +2914,7 @@
           <a:p>
             <a:fld id="{41EA29B2-5B60-4524-9406-F439795E8972}" type="datetimeFigureOut">
               <a:rPr lang="en-US" smtClean="0"/>
-              <a:t>7/8/2025</a:t>
+              <a:t>9/28/2026</a:t>
             </a:fld>
             <a:endParaRPr lang="en-US"/>
           </a:p>
@@ -3358,7 +3363,7 @@
               <a:rPr lang="en-US" dirty="0">
                 <a:latin typeface="+mn-lt"/>
               </a:rPr>
-              <a:t>CSCI E-108</a:t>
+              <a:t>CSCI E-83</a:t>
             </a:r>
             <a:br>
               <a:rPr lang="en-US" dirty="0">
@@ -3369,7 +3374,7 @@
               <a:rPr lang="en-US" dirty="0">
                 <a:latin typeface="+mn-lt"/>
               </a:rPr>
-              <a:t>Data Mining, Discovery and Exploration</a:t>
+              <a:t>Foundations of Data Science II</a:t>
             </a:r>
             <a:br>
               <a:rPr lang="en-US" dirty="0">
@@ -3499,7 +3504,7 @@
             <a:pPr algn="ctr"/>
             <a:r>
               <a:rPr lang="en-US" sz="1100" dirty="0"/>
-              <a:t>Copyright 2021, 2022, 2023, 2024, 2025, Stephen F Elston. All rights reserved</a:t>
+              <a:t>Copyright 2021, 2022, 2023, 2024, 2025, 2026, Stephen F Elston. All rights reserved</a:t>
             </a:r>
             <a:r>
               <a:rPr lang="en-US" dirty="0"/>
@@ -3599,7 +3604,7 @@
         </p:spPr>
         <p:txBody>
           <a:bodyPr>
-            <a:normAutofit/>
+            <a:normAutofit lnSpcReduction="10000"/>
           </a:bodyPr>
           <a:lstStyle/>
           <a:p>
@@ -3622,7 +3627,7 @@
             </a:r>
             <a:r>
               <a:rPr lang="en-US" b="1" dirty="0"/>
-              <a:t>25% of overall grade</a:t>
+              <a:t>30% of overall grade</a:t>
             </a:r>
             <a:r>
               <a:rPr lang="en-US" dirty="0"/>
@@ -3670,7 +3675,14 @@
             <a:pPr lvl="1"/>
             <a:r>
               <a:rPr lang="en-US" dirty="0"/>
-              <a:t>Use data mining methods within the scope of the course to extract information and discover relationships</a:t>
+              <a:t>Submit a proposal</a:t>
+            </a:r>
+          </a:p>
+          <a:p>
+            <a:pPr lvl="1"/>
+            <a:r>
+              <a:rPr lang="en-US" dirty="0"/>
+              <a:t>Use data analysis and inference methods within the scope of the course to extract information and discover relationships</a:t>
             </a:r>
           </a:p>
           <a:p>
@@ -4002,33 +4014,15 @@
                                   </p:childTnLst>
                                 </p:cTn>
                               </p:par>
-                            </p:childTnLst>
-                          </p:cTn>
-                        </p:par>
-                      </p:childTnLst>
-                    </p:cTn>
-                  </p:par>
-                  <p:par>
-                    <p:cTn id="25" fill="hold">
-                      <p:stCondLst>
-                        <p:cond delay="indefinite"/>
-                      </p:stCondLst>
-                      <p:childTnLst>
-                        <p:par>
-                          <p:cTn id="26" fill="hold">
-                            <p:stCondLst>
-                              <p:cond delay="0"/>
-                            </p:stCondLst>
-                            <p:childTnLst>
                               <p:par>
-                                <p:cTn id="27" presetID="1" presetClass="entr" presetSubtype="0" fill="hold" nodeType="clickEffect">
+                                <p:cTn id="25" presetID="1" presetClass="entr" presetSubtype="0" fill="hold" nodeType="withEffect">
                                   <p:stCondLst>
                                     <p:cond delay="0"/>
                                   </p:stCondLst>
                                   <p:childTnLst>
                                     <p:set>
                                       <p:cBhvr>
-                                        <p:cTn id="28" dur="1" fill="hold">
+                                        <p:cTn id="26" dur="1" fill="hold">
                                           <p:stCondLst>
                                             <p:cond delay="0"/>
                                           </p:stCondLst>
@@ -4037,6 +4031,55 @@
                                           <p:spTgt spid="3">
                                             <p:txEl>
                                               <p:pRg st="9" end="9"/>
+                                            </p:txEl>
+                                          </p:spTgt>
+                                        </p:tgtEl>
+                                        <p:attrNameLst>
+                                          <p:attrName>style.visibility</p:attrName>
+                                        </p:attrNameLst>
+                                      </p:cBhvr>
+                                      <p:to>
+                                        <p:strVal val="visible"/>
+                                      </p:to>
+                                    </p:set>
+                                  </p:childTnLst>
+                                </p:cTn>
+                              </p:par>
+                            </p:childTnLst>
+                          </p:cTn>
+                        </p:par>
+                      </p:childTnLst>
+                    </p:cTn>
+                  </p:par>
+                  <p:par>
+                    <p:cTn id="27" fill="hold">
+                      <p:stCondLst>
+                        <p:cond delay="indefinite"/>
+                      </p:stCondLst>
+                      <p:childTnLst>
+                        <p:par>
+                          <p:cTn id="28" fill="hold">
+                            <p:stCondLst>
+                              <p:cond delay="0"/>
+                            </p:stCondLst>
+                            <p:childTnLst>
+                              <p:par>
+                                <p:cTn id="29" presetID="1" presetClass="entr" presetSubtype="0" fill="hold" nodeType="clickEffect">
+                                  <p:stCondLst>
+                                    <p:cond delay="0"/>
+                                  </p:stCondLst>
+                                  <p:childTnLst>
+                                    <p:set>
+                                      <p:cBhvr>
+                                        <p:cTn id="30" dur="1" fill="hold">
+                                          <p:stCondLst>
+                                            <p:cond delay="0"/>
+                                          </p:stCondLst>
+                                        </p:cTn>
+                                        <p:tgtEl>
+                                          <p:spTgt spid="3">
+                                            <p:txEl>
+                                              <p:pRg st="10" end="10"/>
                                             </p:txEl>
                                           </p:spTgt>
                                         </p:tgtEl>
@@ -4200,7 +4243,7 @@
             <a:pPr lvl="1"/>
             <a:r>
               <a:rPr lang="en-US" dirty="0"/>
-              <a:t>This in not a supervised machine learning course: </a:t>
+              <a:t>This in not a machine learning course: </a:t>
             </a:r>
             <a:r>
               <a:rPr lang="en-US" b="1" dirty="0">
@@ -4208,7 +4251,7 @@
                   <a:srgbClr val="C00000"/>
                 </a:solidFill>
               </a:rPr>
-              <a:t>supervised machine learning is not appropriate!</a:t>
+              <a:t>prediction as a goal is generally not appropriate!</a:t>
             </a:r>
           </a:p>
           <a:p>
@@ -4227,7 +4270,7 @@
             </a:r>
             <a:r>
               <a:rPr lang="en-US" dirty="0"/>
-              <a:t>, e.g. clustering project must go beyond k-means and apply several modern methods!</a:t>
+              <a:t>, e.g. must try and compare several regression models like frequentist vs. Bayes!</a:t>
             </a:r>
           </a:p>
           <a:p>
@@ -4710,13 +4753,630 @@
         </p:nvSpPr>
         <p:spPr>
           <a:xfrm>
+            <a:off x="838200" y="1139082"/>
+            <a:ext cx="10515600" cy="5353794"/>
+          </a:xfrm>
+        </p:spPr>
+        <p:txBody>
+          <a:bodyPr>
+            <a:normAutofit/>
+          </a:bodyPr>
+          <a:lstStyle/>
+          <a:p>
+            <a:pPr marL="0" indent="0">
+              <a:buNone/>
+            </a:pPr>
+            <a:r>
+              <a:rPr lang="en-US" b="1" dirty="0"/>
+              <a:t>Suitable projects – only ideas, pick a project that interests you:</a:t>
+            </a:r>
+          </a:p>
+          <a:p>
+            <a:r>
+              <a:rPr lang="en-US" dirty="0"/>
+              <a:t>Suitable methods include, but not limited to:   </a:t>
+            </a:r>
+          </a:p>
+          <a:p>
+            <a:pPr lvl="1"/>
+            <a:r>
+              <a:rPr lang="en-US" dirty="0"/>
+              <a:t>Inference on tabular or time series data – no unstructured data without instructor permission </a:t>
+            </a:r>
+          </a:p>
+          <a:p>
+            <a:pPr lvl="1"/>
+            <a:r>
+              <a:rPr lang="en-US" dirty="0"/>
+              <a:t>Inference with linear models and Bayesian models </a:t>
+            </a:r>
+          </a:p>
+          <a:p>
+            <a:pPr lvl="1"/>
+            <a:r>
+              <a:rPr lang="en-US" dirty="0"/>
+              <a:t>Models for dealing with messy data </a:t>
+            </a:r>
+          </a:p>
+          <a:p>
+            <a:pPr lvl="1"/>
+            <a:r>
+              <a:rPr lang="en-US" b="1" dirty="0"/>
+              <a:t>No supervised machine learning!</a:t>
+            </a:r>
+          </a:p>
+          <a:p>
+            <a:r>
+              <a:rPr lang="en-US" dirty="0"/>
+              <a:t>Suitable data and problems can be drawn from a wide range of domains including, but not limited to:  </a:t>
+            </a:r>
+          </a:p>
+          <a:p>
+            <a:pPr lvl="1"/>
+            <a:r>
+              <a:rPr lang="en-US" dirty="0"/>
+              <a:t>Socioeconomic</a:t>
+            </a:r>
+          </a:p>
+          <a:p>
+            <a:pPr lvl="1"/>
+            <a:r>
+              <a:rPr lang="en-US" dirty="0"/>
+              <a:t>Business and marketing</a:t>
+            </a:r>
+          </a:p>
+          <a:p>
+            <a:pPr lvl="1"/>
+            <a:r>
+              <a:rPr lang="en-US" dirty="0"/>
+              <a:t>Scientific</a:t>
+            </a:r>
+          </a:p>
+          <a:p>
+            <a:pPr lvl="1"/>
+            <a:r>
+              <a:rPr lang="en-US" dirty="0"/>
+              <a:t>Medical</a:t>
+            </a:r>
+          </a:p>
+          <a:p>
+            <a:pPr lvl="1"/>
+            <a:endParaRPr lang="en-US" dirty="0"/>
+          </a:p>
+          <a:p>
+            <a:endParaRPr lang="en-US" dirty="0"/>
+          </a:p>
+          <a:p>
+            <a:endParaRPr lang="en-US" dirty="0"/>
+          </a:p>
+          <a:p>
+            <a:pPr lvl="1"/>
+            <a:endParaRPr lang="en-US" dirty="0"/>
+          </a:p>
+        </p:txBody>
+      </p:sp>
+    </p:spTree>
+    <p:extLst>
+      <p:ext uri="{BB962C8B-B14F-4D97-AF65-F5344CB8AC3E}">
+        <p14:creationId xmlns:p14="http://schemas.microsoft.com/office/powerpoint/2010/main" val="1685102587"/>
+      </p:ext>
+    </p:extLst>
+  </p:cSld>
+  <p:clrMapOvr>
+    <a:masterClrMapping/>
+  </p:clrMapOvr>
+  <p:timing>
+    <p:tnLst>
+      <p:par>
+        <p:cTn id="1" dur="indefinite" restart="never" nodeType="tmRoot">
+          <p:childTnLst>
+            <p:seq concurrent="1" nextAc="seek">
+              <p:cTn id="2" dur="indefinite" nodeType="mainSeq">
+                <p:childTnLst>
+                  <p:par>
+                    <p:cTn id="3" fill="hold">
+                      <p:stCondLst>
+                        <p:cond delay="indefinite"/>
+                      </p:stCondLst>
+                      <p:childTnLst>
+                        <p:par>
+                          <p:cTn id="4" fill="hold">
+                            <p:stCondLst>
+                              <p:cond delay="0"/>
+                            </p:stCondLst>
+                            <p:childTnLst>
+                              <p:par>
+                                <p:cTn id="5" presetID="1" presetClass="entr" presetSubtype="0" fill="hold" nodeType="clickEffect">
+                                  <p:stCondLst>
+                                    <p:cond delay="0"/>
+                                  </p:stCondLst>
+                                  <p:childTnLst>
+                                    <p:set>
+                                      <p:cBhvr>
+                                        <p:cTn id="6" dur="1" fill="hold">
+                                          <p:stCondLst>
+                                            <p:cond delay="0"/>
+                                          </p:stCondLst>
+                                        </p:cTn>
+                                        <p:tgtEl>
+                                          <p:spTgt spid="3">
+                                            <p:txEl>
+                                              <p:pRg st="1" end="1"/>
+                                            </p:txEl>
+                                          </p:spTgt>
+                                        </p:tgtEl>
+                                        <p:attrNameLst>
+                                          <p:attrName>style.visibility</p:attrName>
+                                        </p:attrNameLst>
+                                      </p:cBhvr>
+                                      <p:to>
+                                        <p:strVal val="visible"/>
+                                      </p:to>
+                                    </p:set>
+                                  </p:childTnLst>
+                                </p:cTn>
+                              </p:par>
+                            </p:childTnLst>
+                          </p:cTn>
+                        </p:par>
+                      </p:childTnLst>
+                    </p:cTn>
+                  </p:par>
+                  <p:par>
+                    <p:cTn id="7" fill="hold">
+                      <p:stCondLst>
+                        <p:cond delay="indefinite"/>
+                      </p:stCondLst>
+                      <p:childTnLst>
+                        <p:par>
+                          <p:cTn id="8" fill="hold">
+                            <p:stCondLst>
+                              <p:cond delay="0"/>
+                            </p:stCondLst>
+                            <p:childTnLst>
+                              <p:par>
+                                <p:cTn id="9" presetID="1" presetClass="entr" presetSubtype="0" fill="hold" nodeType="clickEffect">
+                                  <p:stCondLst>
+                                    <p:cond delay="0"/>
+                                  </p:stCondLst>
+                                  <p:childTnLst>
+                                    <p:set>
+                                      <p:cBhvr>
+                                        <p:cTn id="10" dur="1" fill="hold">
+                                          <p:stCondLst>
+                                            <p:cond delay="0"/>
+                                          </p:stCondLst>
+                                        </p:cTn>
+                                        <p:tgtEl>
+                                          <p:spTgt spid="3">
+                                            <p:txEl>
+                                              <p:pRg st="3" end="3"/>
+                                            </p:txEl>
+                                          </p:spTgt>
+                                        </p:tgtEl>
+                                        <p:attrNameLst>
+                                          <p:attrName>style.visibility</p:attrName>
+                                        </p:attrNameLst>
+                                      </p:cBhvr>
+                                      <p:to>
+                                        <p:strVal val="visible"/>
+                                      </p:to>
+                                    </p:set>
+                                  </p:childTnLst>
+                                </p:cTn>
+                              </p:par>
+                            </p:childTnLst>
+                          </p:cTn>
+                        </p:par>
+                      </p:childTnLst>
+                    </p:cTn>
+                  </p:par>
+                  <p:par>
+                    <p:cTn id="11" fill="hold">
+                      <p:stCondLst>
+                        <p:cond delay="indefinite"/>
+                      </p:stCondLst>
+                      <p:childTnLst>
+                        <p:par>
+                          <p:cTn id="12" fill="hold">
+                            <p:stCondLst>
+                              <p:cond delay="0"/>
+                            </p:stCondLst>
+                            <p:childTnLst>
+                              <p:par>
+                                <p:cTn id="13" presetID="1" presetClass="entr" presetSubtype="0" fill="hold" nodeType="clickEffect">
+                                  <p:stCondLst>
+                                    <p:cond delay="0"/>
+                                  </p:stCondLst>
+                                  <p:childTnLst>
+                                    <p:set>
+                                      <p:cBhvr>
+                                        <p:cTn id="14" dur="1" fill="hold">
+                                          <p:stCondLst>
+                                            <p:cond delay="0"/>
+                                          </p:stCondLst>
+                                        </p:cTn>
+                                        <p:tgtEl>
+                                          <p:spTgt spid="3">
+                                            <p:txEl>
+                                              <p:pRg st="4" end="4"/>
+                                            </p:txEl>
+                                          </p:spTgt>
+                                        </p:tgtEl>
+                                        <p:attrNameLst>
+                                          <p:attrName>style.visibility</p:attrName>
+                                        </p:attrNameLst>
+                                      </p:cBhvr>
+                                      <p:to>
+                                        <p:strVal val="visible"/>
+                                      </p:to>
+                                    </p:set>
+                                  </p:childTnLst>
+                                </p:cTn>
+                              </p:par>
+                            </p:childTnLst>
+                          </p:cTn>
+                        </p:par>
+                      </p:childTnLst>
+                    </p:cTn>
+                  </p:par>
+                  <p:par>
+                    <p:cTn id="15" fill="hold">
+                      <p:stCondLst>
+                        <p:cond delay="indefinite"/>
+                      </p:stCondLst>
+                      <p:childTnLst>
+                        <p:par>
+                          <p:cTn id="16" fill="hold">
+                            <p:stCondLst>
+                              <p:cond delay="0"/>
+                            </p:stCondLst>
+                            <p:childTnLst>
+                              <p:par>
+                                <p:cTn id="17" presetID="1" presetClass="entr" presetSubtype="0" fill="hold" nodeType="clickEffect">
+                                  <p:stCondLst>
+                                    <p:cond delay="0"/>
+                                  </p:stCondLst>
+                                  <p:childTnLst>
+                                    <p:set>
+                                      <p:cBhvr>
+                                        <p:cTn id="18" dur="1" fill="hold">
+                                          <p:stCondLst>
+                                            <p:cond delay="0"/>
+                                          </p:stCondLst>
+                                        </p:cTn>
+                                        <p:tgtEl>
+                                          <p:spTgt spid="3">
+                                            <p:txEl>
+                                              <p:pRg st="2" end="2"/>
+                                            </p:txEl>
+                                          </p:spTgt>
+                                        </p:tgtEl>
+                                        <p:attrNameLst>
+                                          <p:attrName>style.visibility</p:attrName>
+                                        </p:attrNameLst>
+                                      </p:cBhvr>
+                                      <p:to>
+                                        <p:strVal val="visible"/>
+                                      </p:to>
+                                    </p:set>
+                                  </p:childTnLst>
+                                </p:cTn>
+                              </p:par>
+                              <p:par>
+                                <p:cTn id="19" presetID="1" presetClass="entr" presetSubtype="0" fill="hold" nodeType="withEffect">
+                                  <p:stCondLst>
+                                    <p:cond delay="0"/>
+                                  </p:stCondLst>
+                                  <p:childTnLst>
+                                    <p:set>
+                                      <p:cBhvr>
+                                        <p:cTn id="20" dur="1" fill="hold">
+                                          <p:stCondLst>
+                                            <p:cond delay="0"/>
+                                          </p:stCondLst>
+                                        </p:cTn>
+                                        <p:tgtEl>
+                                          <p:spTgt spid="3">
+                                            <p:txEl>
+                                              <p:pRg st="5" end="5"/>
+                                            </p:txEl>
+                                          </p:spTgt>
+                                        </p:tgtEl>
+                                        <p:attrNameLst>
+                                          <p:attrName>style.visibility</p:attrName>
+                                        </p:attrNameLst>
+                                      </p:cBhvr>
+                                      <p:to>
+                                        <p:strVal val="visible"/>
+                                      </p:to>
+                                    </p:set>
+                                  </p:childTnLst>
+                                </p:cTn>
+                              </p:par>
+                            </p:childTnLst>
+                          </p:cTn>
+                        </p:par>
+                      </p:childTnLst>
+                    </p:cTn>
+                  </p:par>
+                  <p:par>
+                    <p:cTn id="21" fill="hold">
+                      <p:stCondLst>
+                        <p:cond delay="indefinite"/>
+                      </p:stCondLst>
+                      <p:childTnLst>
+                        <p:par>
+                          <p:cTn id="22" fill="hold">
+                            <p:stCondLst>
+                              <p:cond delay="0"/>
+                            </p:stCondLst>
+                            <p:childTnLst>
+                              <p:par>
+                                <p:cTn id="23" presetID="1" presetClass="entr" presetSubtype="0" fill="hold" nodeType="clickEffect">
+                                  <p:stCondLst>
+                                    <p:cond delay="0"/>
+                                  </p:stCondLst>
+                                  <p:childTnLst>
+                                    <p:set>
+                                      <p:cBhvr>
+                                        <p:cTn id="24" dur="1" fill="hold">
+                                          <p:stCondLst>
+                                            <p:cond delay="0"/>
+                                          </p:stCondLst>
+                                        </p:cTn>
+                                        <p:tgtEl>
+                                          <p:spTgt spid="3">
+                                            <p:txEl>
+                                              <p:pRg st="6" end="6"/>
+                                            </p:txEl>
+                                          </p:spTgt>
+                                        </p:tgtEl>
+                                        <p:attrNameLst>
+                                          <p:attrName>style.visibility</p:attrName>
+                                        </p:attrNameLst>
+                                      </p:cBhvr>
+                                      <p:to>
+                                        <p:strVal val="visible"/>
+                                      </p:to>
+                                    </p:set>
+                                  </p:childTnLst>
+                                </p:cTn>
+                              </p:par>
+                              <p:par>
+                                <p:cTn id="25" presetID="1" presetClass="entr" presetSubtype="0" fill="hold" nodeType="withEffect">
+                                  <p:stCondLst>
+                                    <p:cond delay="0"/>
+                                  </p:stCondLst>
+                                  <p:childTnLst>
+                                    <p:set>
+                                      <p:cBhvr>
+                                        <p:cTn id="26" dur="1" fill="hold">
+                                          <p:stCondLst>
+                                            <p:cond delay="0"/>
+                                          </p:stCondLst>
+                                        </p:cTn>
+                                        <p:tgtEl>
+                                          <p:spTgt spid="3">
+                                            <p:txEl>
+                                              <p:pRg st="7" end="7"/>
+                                            </p:txEl>
+                                          </p:spTgt>
+                                        </p:tgtEl>
+                                        <p:attrNameLst>
+                                          <p:attrName>style.visibility</p:attrName>
+                                        </p:attrNameLst>
+                                      </p:cBhvr>
+                                      <p:to>
+                                        <p:strVal val="visible"/>
+                                      </p:to>
+                                    </p:set>
+                                  </p:childTnLst>
+                                </p:cTn>
+                              </p:par>
+                              <p:par>
+                                <p:cTn id="27" presetID="1" presetClass="entr" presetSubtype="0" fill="hold" nodeType="withEffect">
+                                  <p:stCondLst>
+                                    <p:cond delay="0"/>
+                                  </p:stCondLst>
+                                  <p:childTnLst>
+                                    <p:set>
+                                      <p:cBhvr>
+                                        <p:cTn id="28" dur="1" fill="hold">
+                                          <p:stCondLst>
+                                            <p:cond delay="0"/>
+                                          </p:stCondLst>
+                                        </p:cTn>
+                                        <p:tgtEl>
+                                          <p:spTgt spid="3">
+                                            <p:txEl>
+                                              <p:pRg st="8" end="8"/>
+                                            </p:txEl>
+                                          </p:spTgt>
+                                        </p:tgtEl>
+                                        <p:attrNameLst>
+                                          <p:attrName>style.visibility</p:attrName>
+                                        </p:attrNameLst>
+                                      </p:cBhvr>
+                                      <p:to>
+                                        <p:strVal val="visible"/>
+                                      </p:to>
+                                    </p:set>
+                                  </p:childTnLst>
+                                </p:cTn>
+                              </p:par>
+                              <p:par>
+                                <p:cTn id="29" presetID="1" presetClass="entr" presetSubtype="0" fill="hold" nodeType="withEffect">
+                                  <p:stCondLst>
+                                    <p:cond delay="0"/>
+                                  </p:stCondLst>
+                                  <p:childTnLst>
+                                    <p:set>
+                                      <p:cBhvr>
+                                        <p:cTn id="30" dur="1" fill="hold">
+                                          <p:stCondLst>
+                                            <p:cond delay="0"/>
+                                          </p:stCondLst>
+                                        </p:cTn>
+                                        <p:tgtEl>
+                                          <p:spTgt spid="3">
+                                            <p:txEl>
+                                              <p:pRg st="9" end="9"/>
+                                            </p:txEl>
+                                          </p:spTgt>
+                                        </p:tgtEl>
+                                        <p:attrNameLst>
+                                          <p:attrName>style.visibility</p:attrName>
+                                        </p:attrNameLst>
+                                      </p:cBhvr>
+                                      <p:to>
+                                        <p:strVal val="visible"/>
+                                      </p:to>
+                                    </p:set>
+                                  </p:childTnLst>
+                                </p:cTn>
+                              </p:par>
+                              <p:par>
+                                <p:cTn id="31" presetID="1" presetClass="entr" presetSubtype="0" fill="hold" nodeType="withEffect">
+                                  <p:stCondLst>
+                                    <p:cond delay="0"/>
+                                  </p:stCondLst>
+                                  <p:childTnLst>
+                                    <p:set>
+                                      <p:cBhvr>
+                                        <p:cTn id="32" dur="1" fill="hold">
+                                          <p:stCondLst>
+                                            <p:cond delay="0"/>
+                                          </p:stCondLst>
+                                        </p:cTn>
+                                        <p:tgtEl>
+                                          <p:spTgt spid="3">
+                                            <p:txEl>
+                                              <p:pRg st="10" end="10"/>
+                                            </p:txEl>
+                                          </p:spTgt>
+                                        </p:tgtEl>
+                                        <p:attrNameLst>
+                                          <p:attrName>style.visibility</p:attrName>
+                                        </p:attrNameLst>
+                                      </p:cBhvr>
+                                      <p:to>
+                                        <p:strVal val="visible"/>
+                                      </p:to>
+                                    </p:set>
+                                  </p:childTnLst>
+                                </p:cTn>
+                              </p:par>
+                            </p:childTnLst>
+                          </p:cTn>
+                        </p:par>
+                      </p:childTnLst>
+                    </p:cTn>
+                  </p:par>
+                </p:childTnLst>
+              </p:cTn>
+              <p:prevCondLst>
+                <p:cond evt="onPrev" delay="0">
+                  <p:tgtEl>
+                    <p:sldTgt/>
+                  </p:tgtEl>
+                </p:cond>
+              </p:prevCondLst>
+              <p:nextCondLst>
+                <p:cond evt="onNext" delay="0">
+                  <p:tgtEl>
+                    <p:sldTgt/>
+                  </p:tgtEl>
+                </p:cond>
+              </p:nextCondLst>
+            </p:seq>
+          </p:childTnLst>
+        </p:cTn>
+      </p:par>
+    </p:tnLst>
+  </p:timing>
+</p:sld>
+</file>
+
+<file path=ppt/slides/slide5.xml><?xml version="1.0" encoding="utf-8"?>
+<p:sld xmlns:a="http://schemas.openxmlformats.org/drawingml/2006/main" xmlns:r="http://schemas.openxmlformats.org/officeDocument/2006/relationships" xmlns:p="http://schemas.openxmlformats.org/presentationml/2006/main">
+  <p:cSld>
+    <p:spTree>
+      <p:nvGrpSpPr>
+        <p:cNvPr id="1" name=""/>
+        <p:cNvGrpSpPr/>
+        <p:nvPr/>
+      </p:nvGrpSpPr>
+      <p:grpSpPr>
+        <a:xfrm>
+          <a:off x="0" y="0"/>
+          <a:ext cx="0" cy="0"/>
+          <a:chOff x="0" y="0"/>
+          <a:chExt cx="0" cy="0"/>
+        </a:xfrm>
+      </p:grpSpPr>
+      <p:sp>
+        <p:nvSpPr>
+          <p:cNvPr id="2" name="Title 1">
+            <a:extLst>
+              <a:ext uri="{FF2B5EF4-FFF2-40B4-BE49-F238E27FC236}">
+                <a16:creationId xmlns:a16="http://schemas.microsoft.com/office/drawing/2014/main" id="{1D37A298-CF0B-4DBD-AA56-ED741A667825}"/>
+              </a:ext>
+            </a:extLst>
+          </p:cNvPr>
+          <p:cNvSpPr>
+            <a:spLocks noGrp="1"/>
+          </p:cNvSpPr>
+          <p:nvPr>
+            <p:ph type="title"/>
+          </p:nvPr>
+        </p:nvSpPr>
+        <p:spPr>
+          <a:xfrm>
+            <a:off x="759823" y="0"/>
+            <a:ext cx="10515600" cy="1325563"/>
+          </a:xfrm>
+        </p:spPr>
+        <p:txBody>
+          <a:bodyPr>
+            <a:normAutofit/>
+          </a:bodyPr>
+          <a:lstStyle/>
+          <a:p>
+            <a:r>
+              <a:rPr lang="en-US" sz="4000" dirty="0">
+                <a:latin typeface="+mn-lt"/>
+              </a:rPr>
+              <a:t>Graduate Independent project</a:t>
+            </a:r>
+          </a:p>
+        </p:txBody>
+      </p:sp>
+      <p:sp>
+        <p:nvSpPr>
+          <p:cNvPr id="3" name="Content Placeholder 2">
+            <a:extLst>
+              <a:ext uri="{FF2B5EF4-FFF2-40B4-BE49-F238E27FC236}">
+                <a16:creationId xmlns:a16="http://schemas.microsoft.com/office/drawing/2014/main" id="{BA57A62E-6F15-4A4E-83F9-507340DBCA13}"/>
+              </a:ext>
+            </a:extLst>
+          </p:cNvPr>
+          <p:cNvSpPr>
+            <a:spLocks noGrp="1"/>
+          </p:cNvSpPr>
+          <p:nvPr>
+            <p:ph idx="1"/>
+          </p:nvPr>
+        </p:nvSpPr>
+        <p:spPr>
+          <a:xfrm>
             <a:off x="838200" y="1046375"/>
             <a:ext cx="10515600" cy="5665509"/>
           </a:xfrm>
         </p:spPr>
         <p:txBody>
           <a:bodyPr>
-            <a:normAutofit/>
+            <a:normAutofit lnSpcReduction="10000"/>
           </a:bodyPr>
           <a:lstStyle/>
           <a:p>
@@ -4789,6 +5449,18 @@
             </a:r>
           </a:p>
           <a:p>
+            <a:pPr lvl="1"/>
+            <a:r>
+              <a:rPr lang="en-US" b="1" dirty="0">
+                <a:solidFill>
+                  <a:srgbClr val="C00000"/>
+                </a:solidFill>
+              </a:rPr>
+              <a:t>Outline data preparation steps</a:t>
+            </a:r>
+            <a:endParaRPr lang="en-US" dirty="0"/>
+          </a:p>
+          <a:p>
             <a:r>
               <a:rPr lang="en-US" dirty="0"/>
               <a:t>Use appropriate data mining methods</a:t>
@@ -4800,6 +5472,11 @@
               <a:rPr lang="en-US" dirty="0"/>
               <a:t>Correctly selected for proposed objective</a:t>
             </a:r>
+            <a:endParaRPr lang="en-US" b="1" dirty="0">
+              <a:solidFill>
+                <a:srgbClr val="C00000"/>
+              </a:solidFill>
+            </a:endParaRPr>
           </a:p>
           <a:p>
             <a:pPr lvl="1"/>
@@ -5162,33 +5839,15 @@
                                   </p:childTnLst>
                                 </p:cTn>
                               </p:par>
-                            </p:childTnLst>
-                          </p:cTn>
-                        </p:par>
-                      </p:childTnLst>
-                    </p:cTn>
-                  </p:par>
-                  <p:par>
-                    <p:cTn id="27" fill="hold">
-                      <p:stCondLst>
-                        <p:cond delay="indefinite"/>
-                      </p:stCondLst>
-                      <p:childTnLst>
-                        <p:par>
-                          <p:cTn id="28" fill="hold">
-                            <p:stCondLst>
-                              <p:cond delay="0"/>
-                            </p:stCondLst>
-                            <p:childTnLst>
                               <p:par>
-                                <p:cTn id="29" presetID="1" presetClass="entr" presetSubtype="0" fill="hold" nodeType="clickEffect">
+                                <p:cTn id="27" presetID="1" presetClass="entr" presetSubtype="0" fill="hold" nodeType="withEffect">
                                   <p:stCondLst>
                                     <p:cond delay="0"/>
                                   </p:stCondLst>
                                   <p:childTnLst>
                                     <p:set>
                                       <p:cBhvr>
-                                        <p:cTn id="30" dur="1" fill="hold">
+                                        <p:cTn id="28" dur="1" fill="hold">
                                           <p:stCondLst>
                                             <p:cond delay="0"/>
                                           </p:stCondLst>
@@ -5211,8 +5870,26 @@
                                   </p:childTnLst>
                                 </p:cTn>
                               </p:par>
+                            </p:childTnLst>
+                          </p:cTn>
+                        </p:par>
+                      </p:childTnLst>
+                    </p:cTn>
+                  </p:par>
+                  <p:par>
+                    <p:cTn id="29" fill="hold">
+                      <p:stCondLst>
+                        <p:cond delay="indefinite"/>
+                      </p:stCondLst>
+                      <p:childTnLst>
+                        <p:par>
+                          <p:cTn id="30" fill="hold">
+                            <p:stCondLst>
+                              <p:cond delay="0"/>
+                            </p:stCondLst>
+                            <p:childTnLst>
                               <p:par>
-                                <p:cTn id="31" presetID="1" presetClass="entr" presetSubtype="0" fill="hold" nodeType="withEffect">
+                                <p:cTn id="31" presetID="1" presetClass="entr" presetSubtype="0" fill="hold" nodeType="clickEffect">
                                   <p:stCondLst>
                                     <p:cond delay="0"/>
                                   </p:stCondLst>
@@ -5273,6 +5950,37 @@
                                   </p:childTnLst>
                                 </p:cTn>
                               </p:par>
+                              <p:par>
+                                <p:cTn id="35" presetID="1" presetClass="entr" presetSubtype="0" fill="hold" nodeType="withEffect">
+                                  <p:stCondLst>
+                                    <p:cond delay="0"/>
+                                  </p:stCondLst>
+                                  <p:childTnLst>
+                                    <p:set>
+                                      <p:cBhvr>
+                                        <p:cTn id="36" dur="1" fill="hold">
+                                          <p:stCondLst>
+                                            <p:cond delay="0"/>
+                                          </p:stCondLst>
+                                        </p:cTn>
+                                        <p:tgtEl>
+                                          <p:spTgt spid="3">
+                                            <p:txEl>
+                                              <p:pRg st="13" end="13"/>
+                                            </p:txEl>
+                                          </p:spTgt>
+                                        </p:tgtEl>
+                                        <p:attrNameLst>
+                                          <p:attrName>style.visibility</p:attrName>
+                                        </p:attrNameLst>
+                                      </p:cBhvr>
+                                      <p:to>
+                                        <p:strVal val="visible"/>
+                                      </p:to>
+                                    </p:set>
+                                  </p:childTnLst>
+                                </p:cTn>
+                              </p:par>
                             </p:childTnLst>
                           </p:cTn>
                         </p:par>
@@ -5304,7 +6012,7 @@
 </p:sld>
 </file>
 
-<file path=ppt/slides/slide5.xml><?xml version="1.0" encoding="utf-8"?>
+<file path=ppt/slides/slide6.xml><?xml version="1.0" encoding="utf-8"?>
 <p:sld xmlns:a="http://schemas.openxmlformats.org/drawingml/2006/main" xmlns:r="http://schemas.openxmlformats.org/officeDocument/2006/relationships" xmlns:p="http://schemas.openxmlformats.org/presentationml/2006/main">
   <p:cSld>
     <p:spTree>
@@ -5382,7 +6090,7 @@
         </p:spPr>
         <p:txBody>
           <a:bodyPr>
-            <a:normAutofit fontScale="92500" lnSpcReduction="10000"/>
+            <a:normAutofit fontScale="92500" lnSpcReduction="20000"/>
           </a:bodyPr>
           <a:lstStyle/>
           <a:p>
@@ -5397,13 +6105,36 @@
           <a:p>
             <a:r>
               <a:rPr lang="en-US" dirty="0"/>
-              <a:t>Have introduction (summary) stating objectives and conclusions, understandable to the intended non-technical audience  </a:t>
-            </a:r>
-          </a:p>
-          <a:p>
+              <a:t>Have introduction (summary) stating objectives, </a:t>
+            </a:r>
+            <a:r>
+              <a:rPr lang="en-US" b="1" dirty="0">
+                <a:solidFill>
+                  <a:srgbClr val="C00000"/>
+                </a:solidFill>
+              </a:rPr>
+              <a:t>discoveries</a:t>
+            </a:r>
             <a:r>
               <a:rPr lang="en-US" dirty="0"/>
-              <a:t>Support conclusions based on evidence gathered in the data mining process</a:t>
+              <a:t> and conclusions, understandable to the intended non-technical audience  </a:t>
+            </a:r>
+          </a:p>
+          <a:p>
+            <a:r>
+              <a:rPr lang="en-US" dirty="0"/>
+              <a:t>Support conclusions and discoveries based on evidence gathered in the data mining process</a:t>
+            </a:r>
+          </a:p>
+          <a:p>
+            <a:pPr lvl="1"/>
+            <a:r>
+              <a:rPr lang="en-US" b="1" dirty="0">
+                <a:solidFill>
+                  <a:srgbClr val="C00000"/>
+                </a:solidFill>
+              </a:rPr>
+              <a:t>Conclusions and discoveries must be supported by rigorous inference!</a:t>
             </a:r>
           </a:p>
           <a:p>
@@ -5415,7 +6146,7 @@
           <a:p>
             <a:r>
               <a:rPr lang="en-US" dirty="0"/>
-              <a:t>Explain the data exploration and knowledge discovery process</a:t>
+              <a:t>Explain the data exploration and discoveries</a:t>
             </a:r>
           </a:p>
           <a:p>
@@ -5453,8 +6184,13 @@
             </a:r>
             <a:r>
               <a:rPr lang="en-US" b="1" dirty="0"/>
-              <a:t>enhancing methods or using other algorithms</a:t>
-            </a:r>
+              <a:t>enhancing methods or using </a:t>
+            </a:r>
+            <a:r>
+              <a:rPr lang="en-US" b="1"/>
+              <a:t>other methods</a:t>
+            </a:r>
+            <a:endParaRPr lang="en-US" b="1" dirty="0"/>
           </a:p>
           <a:p>
             <a:r>
@@ -5679,15 +6415,33 @@
                                   </p:childTnLst>
                                 </p:cTn>
                               </p:par>
+                            </p:childTnLst>
+                          </p:cTn>
+                        </p:par>
+                      </p:childTnLst>
+                    </p:cTn>
+                  </p:par>
+                  <p:par>
+                    <p:cTn id="19" fill="hold">
+                      <p:stCondLst>
+                        <p:cond delay="indefinite"/>
+                      </p:stCondLst>
+                      <p:childTnLst>
+                        <p:par>
+                          <p:cTn id="20" fill="hold">
+                            <p:stCondLst>
+                              <p:cond delay="0"/>
+                            </p:stCondLst>
+                            <p:childTnLst>
                               <p:par>
-                                <p:cTn id="19" presetID="1" presetClass="entr" presetSubtype="0" fill="hold" nodeType="withEffect">
+                                <p:cTn id="21" presetID="1" presetClass="entr" presetSubtype="0" fill="hold" nodeType="clickEffect">
                                   <p:stCondLst>
                                     <p:cond delay="0"/>
                                   </p:stCondLst>
                                   <p:childTnLst>
                                     <p:set>
                                       <p:cBhvr>
-                                        <p:cTn id="20" dur="1" fill="hold">
+                                        <p:cTn id="22" dur="1" fill="hold">
                                           <p:stCondLst>
                                             <p:cond delay="0"/>
                                           </p:stCondLst>
@@ -5711,14 +6465,14 @@
                                 </p:cTn>
                               </p:par>
                               <p:par>
-                                <p:cTn id="21" presetID="1" presetClass="entr" presetSubtype="0" fill="hold" nodeType="withEffect">
+                                <p:cTn id="23" presetID="1" presetClass="entr" presetSubtype="0" fill="hold" nodeType="withEffect">
                                   <p:stCondLst>
                                     <p:cond delay="0"/>
                                   </p:stCondLst>
                                   <p:childTnLst>
                                     <p:set>
                                       <p:cBhvr>
-                                        <p:cTn id="22" dur="1" fill="hold">
+                                        <p:cTn id="24" dur="1" fill="hold">
                                           <p:stCondLst>
                                             <p:cond delay="0"/>
                                           </p:stCondLst>
@@ -5741,26 +6495,8 @@
                                   </p:childTnLst>
                                 </p:cTn>
                               </p:par>
-                            </p:childTnLst>
-                          </p:cTn>
-                        </p:par>
-                      </p:childTnLst>
-                    </p:cTn>
-                  </p:par>
-                  <p:par>
-                    <p:cTn id="23" fill="hold">
-                      <p:stCondLst>
-                        <p:cond delay="indefinite"/>
-                      </p:stCondLst>
-                      <p:childTnLst>
-                        <p:par>
-                          <p:cTn id="24" fill="hold">
-                            <p:stCondLst>
-                              <p:cond delay="0"/>
-                            </p:stCondLst>
-                            <p:childTnLst>
                               <p:par>
-                                <p:cTn id="25" presetID="1" presetClass="entr" presetSubtype="0" fill="hold" nodeType="clickEffect">
+                                <p:cTn id="25" presetID="1" presetClass="entr" presetSubtype="0" fill="hold" nodeType="withEffect">
                                   <p:stCondLst>
                                     <p:cond delay="0"/>
                                   </p:stCondLst>
@@ -5790,15 +6526,33 @@
                                   </p:childTnLst>
                                 </p:cTn>
                               </p:par>
+                            </p:childTnLst>
+                          </p:cTn>
+                        </p:par>
+                      </p:childTnLst>
+                    </p:cTn>
+                  </p:par>
+                  <p:par>
+                    <p:cTn id="27" fill="hold">
+                      <p:stCondLst>
+                        <p:cond delay="indefinite"/>
+                      </p:stCondLst>
+                      <p:childTnLst>
+                        <p:par>
+                          <p:cTn id="28" fill="hold">
+                            <p:stCondLst>
+                              <p:cond delay="0"/>
+                            </p:stCondLst>
+                            <p:childTnLst>
                               <p:par>
-                                <p:cTn id="27" presetID="1" presetClass="entr" presetSubtype="0" fill="hold" nodeType="withEffect">
+                                <p:cTn id="29" presetID="1" presetClass="entr" presetSubtype="0" fill="hold" nodeType="clickEffect">
                                   <p:stCondLst>
                                     <p:cond delay="0"/>
                                   </p:stCondLst>
                                   <p:childTnLst>
                                     <p:set>
                                       <p:cBhvr>
-                                        <p:cTn id="28" dur="1" fill="hold">
+                                        <p:cTn id="30" dur="1" fill="hold">
                                           <p:stCondLst>
                                             <p:cond delay="0"/>
                                           </p:stCondLst>
@@ -5821,26 +6575,8 @@
                                   </p:childTnLst>
                                 </p:cTn>
                               </p:par>
-                            </p:childTnLst>
-                          </p:cTn>
-                        </p:par>
-                      </p:childTnLst>
-                    </p:cTn>
-                  </p:par>
-                  <p:par>
-                    <p:cTn id="29" fill="hold">
-                      <p:stCondLst>
-                        <p:cond delay="indefinite"/>
-                      </p:stCondLst>
-                      <p:childTnLst>
-                        <p:par>
-                          <p:cTn id="30" fill="hold">
-                            <p:stCondLst>
-                              <p:cond delay="0"/>
-                            </p:stCondLst>
-                            <p:childTnLst>
                               <p:par>
-                                <p:cTn id="31" presetID="1" presetClass="entr" presetSubtype="0" fill="hold" nodeType="clickEffect">
+                                <p:cTn id="31" presetID="1" presetClass="entr" presetSubtype="0" fill="hold" nodeType="withEffect">
                                   <p:stCondLst>
                                     <p:cond delay="0"/>
                                   </p:stCondLst>
@@ -5925,586 +6661,27 @@
                       </p:childTnLst>
                     </p:cTn>
                   </p:par>
-                </p:childTnLst>
-              </p:cTn>
-              <p:prevCondLst>
-                <p:cond evt="onPrev" delay="0">
-                  <p:tgtEl>
-                    <p:sldTgt/>
-                  </p:tgtEl>
-                </p:cond>
-              </p:prevCondLst>
-              <p:nextCondLst>
-                <p:cond evt="onNext" delay="0">
-                  <p:tgtEl>
-                    <p:sldTgt/>
-                  </p:tgtEl>
-                </p:cond>
-              </p:nextCondLst>
-            </p:seq>
-          </p:childTnLst>
-        </p:cTn>
-      </p:par>
-    </p:tnLst>
-  </p:timing>
-</p:sld>
-</file>
-
-<file path=ppt/slides/slide6.xml><?xml version="1.0" encoding="utf-8"?>
-<p:sld xmlns:a="http://schemas.openxmlformats.org/drawingml/2006/main" xmlns:r="http://schemas.openxmlformats.org/officeDocument/2006/relationships" xmlns:p="http://schemas.openxmlformats.org/presentationml/2006/main">
-  <p:cSld>
-    <p:spTree>
-      <p:nvGrpSpPr>
-        <p:cNvPr id="1" name=""/>
-        <p:cNvGrpSpPr/>
-        <p:nvPr/>
-      </p:nvGrpSpPr>
-      <p:grpSpPr>
-        <a:xfrm>
-          <a:off x="0" y="0"/>
-          <a:ext cx="0" cy="0"/>
-          <a:chOff x="0" y="0"/>
-          <a:chExt cx="0" cy="0"/>
-        </a:xfrm>
-      </p:grpSpPr>
-      <p:sp>
-        <p:nvSpPr>
-          <p:cNvPr id="2" name="Title 1">
-            <a:extLst>
-              <a:ext uri="{FF2B5EF4-FFF2-40B4-BE49-F238E27FC236}">
-                <a16:creationId xmlns:a16="http://schemas.microsoft.com/office/drawing/2014/main" id="{1D37A298-CF0B-4DBD-AA56-ED741A667825}"/>
-              </a:ext>
-            </a:extLst>
-          </p:cNvPr>
-          <p:cNvSpPr>
-            <a:spLocks noGrp="1"/>
-          </p:cNvSpPr>
-          <p:nvPr>
-            <p:ph type="title"/>
-          </p:nvPr>
-        </p:nvSpPr>
-        <p:spPr>
-          <a:xfrm>
-            <a:off x="759823" y="0"/>
-            <a:ext cx="10515600" cy="1325563"/>
-          </a:xfrm>
-        </p:spPr>
-        <p:txBody>
-          <a:bodyPr>
-            <a:normAutofit/>
-          </a:bodyPr>
-          <a:lstStyle/>
-          <a:p>
-            <a:r>
-              <a:rPr lang="en-US" sz="4000" dirty="0">
-                <a:latin typeface="+mn-lt"/>
-              </a:rPr>
-              <a:t>Graduate Independent project</a:t>
-            </a:r>
-          </a:p>
-        </p:txBody>
-      </p:sp>
-      <p:sp>
-        <p:nvSpPr>
-          <p:cNvPr id="3" name="Content Placeholder 2">
-            <a:extLst>
-              <a:ext uri="{FF2B5EF4-FFF2-40B4-BE49-F238E27FC236}">
-                <a16:creationId xmlns:a16="http://schemas.microsoft.com/office/drawing/2014/main" id="{BA57A62E-6F15-4A4E-83F9-507340DBCA13}"/>
-              </a:ext>
-            </a:extLst>
-          </p:cNvPr>
-          <p:cNvSpPr>
-            <a:spLocks noGrp="1"/>
-          </p:cNvSpPr>
-          <p:nvPr>
-            <p:ph idx="1"/>
-          </p:nvPr>
-        </p:nvSpPr>
-        <p:spPr>
-          <a:xfrm>
-            <a:off x="838200" y="1139082"/>
-            <a:ext cx="10515600" cy="5353794"/>
-          </a:xfrm>
-        </p:spPr>
-        <p:txBody>
-          <a:bodyPr>
-            <a:normAutofit lnSpcReduction="10000"/>
-          </a:bodyPr>
-          <a:lstStyle/>
-          <a:p>
-            <a:pPr marL="0" indent="0">
-              <a:buNone/>
-            </a:pPr>
-            <a:r>
-              <a:rPr lang="en-US" b="1" dirty="0"/>
-              <a:t>Suitable projects – only ideas, pick a project that interests you:</a:t>
-            </a:r>
-          </a:p>
-          <a:p>
-            <a:r>
-              <a:rPr lang="en-US" dirty="0"/>
-              <a:t>Suitable methods include, but not limited to:   </a:t>
-            </a:r>
-          </a:p>
-          <a:p>
-            <a:pPr lvl="1"/>
-            <a:r>
-              <a:rPr lang="en-US" dirty="0"/>
-              <a:t>Unsupervised learning – many possible models</a:t>
-            </a:r>
-          </a:p>
-          <a:p>
-            <a:pPr lvl="1"/>
-            <a:r>
-              <a:rPr lang="en-US" dirty="0"/>
-              <a:t>Large scale similarity measures  </a:t>
-            </a:r>
-          </a:p>
-          <a:p>
-            <a:pPr lvl="1"/>
-            <a:r>
-              <a:rPr lang="en-US" dirty="0"/>
-              <a:t>Recommenders and factorization   </a:t>
-            </a:r>
-          </a:p>
-          <a:p>
-            <a:pPr lvl="1"/>
-            <a:r>
-              <a:rPr lang="en-US" dirty="0"/>
-              <a:t>Graph models </a:t>
-            </a:r>
-          </a:p>
-          <a:p>
-            <a:pPr lvl="1"/>
-            <a:r>
-              <a:rPr lang="en-US" b="1" dirty="0"/>
-              <a:t>Not supervised machine learning!</a:t>
-            </a:r>
-          </a:p>
-          <a:p>
-            <a:r>
-              <a:rPr lang="en-US" dirty="0"/>
-              <a:t>Suitable datasets and problems include, but not limited to:  </a:t>
-            </a:r>
-          </a:p>
-          <a:p>
-            <a:pPr lvl="1"/>
-            <a:r>
-              <a:rPr lang="en-US" dirty="0"/>
-              <a:t>Genetic data and gene expression</a:t>
-            </a:r>
-          </a:p>
-          <a:p>
-            <a:pPr lvl="1"/>
-            <a:r>
-              <a:rPr lang="en-US" dirty="0"/>
-              <a:t>Text data, information retrieval, similarity search, etc.</a:t>
-            </a:r>
-          </a:p>
-          <a:p>
-            <a:pPr lvl="1"/>
-            <a:r>
-              <a:rPr lang="en-US" dirty="0"/>
-              <a:t>Streaming and large-scale time series data, event processing   </a:t>
-            </a:r>
-          </a:p>
-          <a:p>
-            <a:pPr lvl="1"/>
-            <a:r>
-              <a:rPr lang="en-US" dirty="0"/>
-              <a:t>Product recommendation data </a:t>
-            </a:r>
-          </a:p>
-          <a:p>
-            <a:pPr lvl="1"/>
-            <a:r>
-              <a:rPr lang="en-US" dirty="0"/>
-              <a:t>Graph data, social networks, etc. </a:t>
-            </a:r>
-          </a:p>
-          <a:p>
-            <a:pPr lvl="1"/>
-            <a:endParaRPr lang="en-US" dirty="0"/>
-          </a:p>
-          <a:p>
-            <a:endParaRPr lang="en-US" dirty="0"/>
-          </a:p>
-          <a:p>
-            <a:endParaRPr lang="en-US" dirty="0"/>
-          </a:p>
-          <a:p>
-            <a:pPr lvl="1"/>
-            <a:endParaRPr lang="en-US" dirty="0"/>
-          </a:p>
-        </p:txBody>
-      </p:sp>
-    </p:spTree>
-    <p:extLst>
-      <p:ext uri="{BB962C8B-B14F-4D97-AF65-F5344CB8AC3E}">
-        <p14:creationId xmlns:p14="http://schemas.microsoft.com/office/powerpoint/2010/main" val="1685102587"/>
-      </p:ext>
-    </p:extLst>
-  </p:cSld>
-  <p:clrMapOvr>
-    <a:masterClrMapping/>
-  </p:clrMapOvr>
-  <p:timing>
-    <p:tnLst>
-      <p:par>
-        <p:cTn id="1" dur="indefinite" restart="never" nodeType="tmRoot">
-          <p:childTnLst>
-            <p:seq concurrent="1" nextAc="seek">
-              <p:cTn id="2" dur="indefinite" nodeType="mainSeq">
-                <p:childTnLst>
                   <p:par>
-                    <p:cTn id="3" fill="hold">
+                    <p:cTn id="37" fill="hold">
                       <p:stCondLst>
                         <p:cond delay="indefinite"/>
                       </p:stCondLst>
                       <p:childTnLst>
                         <p:par>
-                          <p:cTn id="4" fill="hold">
+                          <p:cTn id="38" fill="hold">
                             <p:stCondLst>
                               <p:cond delay="0"/>
                             </p:stCondLst>
                             <p:childTnLst>
                               <p:par>
-                                <p:cTn id="5" presetID="1" presetClass="entr" presetSubtype="0" fill="hold" nodeType="clickEffect">
+                                <p:cTn id="39" presetID="1" presetClass="entr" presetSubtype="0" fill="hold" nodeType="clickEffect">
                                   <p:stCondLst>
                                     <p:cond delay="0"/>
                                   </p:stCondLst>
                                   <p:childTnLst>
                                     <p:set>
                                       <p:cBhvr>
-                                        <p:cTn id="6" dur="1" fill="hold">
-                                          <p:stCondLst>
-                                            <p:cond delay="0"/>
-                                          </p:stCondLst>
-                                        </p:cTn>
-                                        <p:tgtEl>
-                                          <p:spTgt spid="3">
-                                            <p:txEl>
-                                              <p:pRg st="1" end="1"/>
-                                            </p:txEl>
-                                          </p:spTgt>
-                                        </p:tgtEl>
-                                        <p:attrNameLst>
-                                          <p:attrName>style.visibility</p:attrName>
-                                        </p:attrNameLst>
-                                      </p:cBhvr>
-                                      <p:to>
-                                        <p:strVal val="visible"/>
-                                      </p:to>
-                                    </p:set>
-                                  </p:childTnLst>
-                                </p:cTn>
-                              </p:par>
-                              <p:par>
-                                <p:cTn id="7" presetID="1" presetClass="entr" presetSubtype="0" fill="hold" nodeType="withEffect">
-                                  <p:stCondLst>
-                                    <p:cond delay="0"/>
-                                  </p:stCondLst>
-                                  <p:childTnLst>
-                                    <p:set>
-                                      <p:cBhvr>
-                                        <p:cTn id="8" dur="1" fill="hold">
-                                          <p:stCondLst>
-                                            <p:cond delay="0"/>
-                                          </p:stCondLst>
-                                        </p:cTn>
-                                        <p:tgtEl>
-                                          <p:spTgt spid="3">
-                                            <p:txEl>
-                                              <p:pRg st="2" end="2"/>
-                                            </p:txEl>
-                                          </p:spTgt>
-                                        </p:tgtEl>
-                                        <p:attrNameLst>
-                                          <p:attrName>style.visibility</p:attrName>
-                                        </p:attrNameLst>
-                                      </p:cBhvr>
-                                      <p:to>
-                                        <p:strVal val="visible"/>
-                                      </p:to>
-                                    </p:set>
-                                  </p:childTnLst>
-                                </p:cTn>
-                              </p:par>
-                              <p:par>
-                                <p:cTn id="9" presetID="1" presetClass="entr" presetSubtype="0" fill="hold" nodeType="withEffect">
-                                  <p:stCondLst>
-                                    <p:cond delay="0"/>
-                                  </p:stCondLst>
-                                  <p:childTnLst>
-                                    <p:set>
-                                      <p:cBhvr>
-                                        <p:cTn id="10" dur="1" fill="hold">
-                                          <p:stCondLst>
-                                            <p:cond delay="0"/>
-                                          </p:stCondLst>
-                                        </p:cTn>
-                                        <p:tgtEl>
-                                          <p:spTgt spid="3">
-                                            <p:txEl>
-                                              <p:pRg st="3" end="3"/>
-                                            </p:txEl>
-                                          </p:spTgt>
-                                        </p:tgtEl>
-                                        <p:attrNameLst>
-                                          <p:attrName>style.visibility</p:attrName>
-                                        </p:attrNameLst>
-                                      </p:cBhvr>
-                                      <p:to>
-                                        <p:strVal val="visible"/>
-                                      </p:to>
-                                    </p:set>
-                                  </p:childTnLst>
-                                </p:cTn>
-                              </p:par>
-                              <p:par>
-                                <p:cTn id="11" presetID="1" presetClass="entr" presetSubtype="0" fill="hold" nodeType="withEffect">
-                                  <p:stCondLst>
-                                    <p:cond delay="0"/>
-                                  </p:stCondLst>
-                                  <p:childTnLst>
-                                    <p:set>
-                                      <p:cBhvr>
-                                        <p:cTn id="12" dur="1" fill="hold">
-                                          <p:stCondLst>
-                                            <p:cond delay="0"/>
-                                          </p:stCondLst>
-                                        </p:cTn>
-                                        <p:tgtEl>
-                                          <p:spTgt spid="3">
-                                            <p:txEl>
-                                              <p:pRg st="4" end="4"/>
-                                            </p:txEl>
-                                          </p:spTgt>
-                                        </p:tgtEl>
-                                        <p:attrNameLst>
-                                          <p:attrName>style.visibility</p:attrName>
-                                        </p:attrNameLst>
-                                      </p:cBhvr>
-                                      <p:to>
-                                        <p:strVal val="visible"/>
-                                      </p:to>
-                                    </p:set>
-                                  </p:childTnLst>
-                                </p:cTn>
-                              </p:par>
-                              <p:par>
-                                <p:cTn id="13" presetID="1" presetClass="entr" presetSubtype="0" fill="hold" nodeType="withEffect">
-                                  <p:stCondLst>
-                                    <p:cond delay="0"/>
-                                  </p:stCondLst>
-                                  <p:childTnLst>
-                                    <p:set>
-                                      <p:cBhvr>
-                                        <p:cTn id="14" dur="1" fill="hold">
-                                          <p:stCondLst>
-                                            <p:cond delay="0"/>
-                                          </p:stCondLst>
-                                        </p:cTn>
-                                        <p:tgtEl>
-                                          <p:spTgt spid="3">
-                                            <p:txEl>
-                                              <p:pRg st="5" end="5"/>
-                                            </p:txEl>
-                                          </p:spTgt>
-                                        </p:tgtEl>
-                                        <p:attrNameLst>
-                                          <p:attrName>style.visibility</p:attrName>
-                                        </p:attrNameLst>
-                                      </p:cBhvr>
-                                      <p:to>
-                                        <p:strVal val="visible"/>
-                                      </p:to>
-                                    </p:set>
-                                  </p:childTnLst>
-                                </p:cTn>
-                              </p:par>
-                              <p:par>
-                                <p:cTn id="15" presetID="1" presetClass="entr" presetSubtype="0" fill="hold" nodeType="withEffect">
-                                  <p:stCondLst>
-                                    <p:cond delay="0"/>
-                                  </p:stCondLst>
-                                  <p:childTnLst>
-                                    <p:set>
-                                      <p:cBhvr>
-                                        <p:cTn id="16" dur="1" fill="hold">
-                                          <p:stCondLst>
-                                            <p:cond delay="0"/>
-                                          </p:stCondLst>
-                                        </p:cTn>
-                                        <p:tgtEl>
-                                          <p:spTgt spid="3">
-                                            <p:txEl>
-                                              <p:pRg st="6" end="6"/>
-                                            </p:txEl>
-                                          </p:spTgt>
-                                        </p:tgtEl>
-                                        <p:attrNameLst>
-                                          <p:attrName>style.visibility</p:attrName>
-                                        </p:attrNameLst>
-                                      </p:cBhvr>
-                                      <p:to>
-                                        <p:strVal val="visible"/>
-                                      </p:to>
-                                    </p:set>
-                                  </p:childTnLst>
-                                </p:cTn>
-                              </p:par>
-                            </p:childTnLst>
-                          </p:cTn>
-                        </p:par>
-                      </p:childTnLst>
-                    </p:cTn>
-                  </p:par>
-                  <p:par>
-                    <p:cTn id="17" fill="hold">
-                      <p:stCondLst>
-                        <p:cond delay="indefinite"/>
-                      </p:stCondLst>
-                      <p:childTnLst>
-                        <p:par>
-                          <p:cTn id="18" fill="hold">
-                            <p:stCondLst>
-                              <p:cond delay="0"/>
-                            </p:stCondLst>
-                            <p:childTnLst>
-                              <p:par>
-                                <p:cTn id="19" presetID="1" presetClass="entr" presetSubtype="0" fill="hold" nodeType="clickEffect">
-                                  <p:stCondLst>
-                                    <p:cond delay="0"/>
-                                  </p:stCondLst>
-                                  <p:childTnLst>
-                                    <p:set>
-                                      <p:cBhvr>
-                                        <p:cTn id="20" dur="1" fill="hold">
-                                          <p:stCondLst>
-                                            <p:cond delay="0"/>
-                                          </p:stCondLst>
-                                        </p:cTn>
-                                        <p:tgtEl>
-                                          <p:spTgt spid="3">
-                                            <p:txEl>
-                                              <p:pRg st="7" end="7"/>
-                                            </p:txEl>
-                                          </p:spTgt>
-                                        </p:tgtEl>
-                                        <p:attrNameLst>
-                                          <p:attrName>style.visibility</p:attrName>
-                                        </p:attrNameLst>
-                                      </p:cBhvr>
-                                      <p:to>
-                                        <p:strVal val="visible"/>
-                                      </p:to>
-                                    </p:set>
-                                  </p:childTnLst>
-                                </p:cTn>
-                              </p:par>
-                              <p:par>
-                                <p:cTn id="21" presetID="1" presetClass="entr" presetSubtype="0" fill="hold" nodeType="withEffect">
-                                  <p:stCondLst>
-                                    <p:cond delay="0"/>
-                                  </p:stCondLst>
-                                  <p:childTnLst>
-                                    <p:set>
-                                      <p:cBhvr>
-                                        <p:cTn id="22" dur="1" fill="hold">
-                                          <p:stCondLst>
-                                            <p:cond delay="0"/>
-                                          </p:stCondLst>
-                                        </p:cTn>
-                                        <p:tgtEl>
-                                          <p:spTgt spid="3">
-                                            <p:txEl>
-                                              <p:pRg st="8" end="8"/>
-                                            </p:txEl>
-                                          </p:spTgt>
-                                        </p:tgtEl>
-                                        <p:attrNameLst>
-                                          <p:attrName>style.visibility</p:attrName>
-                                        </p:attrNameLst>
-                                      </p:cBhvr>
-                                      <p:to>
-                                        <p:strVal val="visible"/>
-                                      </p:to>
-                                    </p:set>
-                                  </p:childTnLst>
-                                </p:cTn>
-                              </p:par>
-                              <p:par>
-                                <p:cTn id="23" presetID="1" presetClass="entr" presetSubtype="0" fill="hold" nodeType="withEffect">
-                                  <p:stCondLst>
-                                    <p:cond delay="0"/>
-                                  </p:stCondLst>
-                                  <p:childTnLst>
-                                    <p:set>
-                                      <p:cBhvr>
-                                        <p:cTn id="24" dur="1" fill="hold">
-                                          <p:stCondLst>
-                                            <p:cond delay="0"/>
-                                          </p:stCondLst>
-                                        </p:cTn>
-                                        <p:tgtEl>
-                                          <p:spTgt spid="3">
-                                            <p:txEl>
-                                              <p:pRg st="9" end="9"/>
-                                            </p:txEl>
-                                          </p:spTgt>
-                                        </p:tgtEl>
-                                        <p:attrNameLst>
-                                          <p:attrName>style.visibility</p:attrName>
-                                        </p:attrNameLst>
-                                      </p:cBhvr>
-                                      <p:to>
-                                        <p:strVal val="visible"/>
-                                      </p:to>
-                                    </p:set>
-                                  </p:childTnLst>
-                                </p:cTn>
-                              </p:par>
-                              <p:par>
-                                <p:cTn id="25" presetID="1" presetClass="entr" presetSubtype="0" fill="hold" nodeType="withEffect">
-                                  <p:stCondLst>
-                                    <p:cond delay="0"/>
-                                  </p:stCondLst>
-                                  <p:childTnLst>
-                                    <p:set>
-                                      <p:cBhvr>
-                                        <p:cTn id="26" dur="1" fill="hold">
-                                          <p:stCondLst>
-                                            <p:cond delay="0"/>
-                                          </p:stCondLst>
-                                        </p:cTn>
-                                        <p:tgtEl>
-                                          <p:spTgt spid="3">
-                                            <p:txEl>
-                                              <p:pRg st="10" end="10"/>
-                                            </p:txEl>
-                                          </p:spTgt>
-                                        </p:tgtEl>
-                                        <p:attrNameLst>
-                                          <p:attrName>style.visibility</p:attrName>
-                                        </p:attrNameLst>
-                                      </p:cBhvr>
-                                      <p:to>
-                                        <p:strVal val="visible"/>
-                                      </p:to>
-                                    </p:set>
-                                  </p:childTnLst>
-                                </p:cTn>
-                              </p:par>
-                              <p:par>
-                                <p:cTn id="27" presetID="1" presetClass="entr" presetSubtype="0" fill="hold" nodeType="withEffect">
-                                  <p:stCondLst>
-                                    <p:cond delay="0"/>
-                                  </p:stCondLst>
-                                  <p:childTnLst>
-                                    <p:set>
-                                      <p:cBhvr>
-                                        <p:cTn id="28" dur="1" fill="hold">
+                                        <p:cTn id="40" dur="1" fill="hold">
                                           <p:stCondLst>
                                             <p:cond delay="0"/>
                                           </p:stCondLst>
@@ -6513,37 +6690,6 @@
                                           <p:spTgt spid="3">
                                             <p:txEl>
                                               <p:pRg st="11" end="11"/>
-                                            </p:txEl>
-                                          </p:spTgt>
-                                        </p:tgtEl>
-                                        <p:attrNameLst>
-                                          <p:attrName>style.visibility</p:attrName>
-                                        </p:attrNameLst>
-                                      </p:cBhvr>
-                                      <p:to>
-                                        <p:strVal val="visible"/>
-                                      </p:to>
-                                    </p:set>
-                                  </p:childTnLst>
-                                </p:cTn>
-                              </p:par>
-                              <p:par>
-                                <p:cTn id="29" presetID="1" presetClass="entr" presetSubtype="0" fill="hold" nodeType="withEffect">
-                                  <p:stCondLst>
-                                    <p:cond delay="0"/>
-                                  </p:stCondLst>
-                                  <p:childTnLst>
-                                    <p:set>
-                                      <p:cBhvr>
-                                        <p:cTn id="30" dur="1" fill="hold">
-                                          <p:stCondLst>
-                                            <p:cond delay="0"/>
-                                          </p:stCondLst>
-                                        </p:cTn>
-                                        <p:tgtEl>
-                                          <p:spTgt spid="3">
-                                            <p:txEl>
-                                              <p:pRg st="12" end="12"/>
                                             </p:txEl>
                                           </p:spTgt>
                                         </p:tgtEl>

</xml_diff>

<commit_message>
Corrections from section meeting
</commit_message>
<xml_diff>
--- a/SupplementaryMaterials/GraduateIndependentProject.pptx
+++ b/SupplementaryMaterials/GraduateIndependentProject.pptx
@@ -264,7 +264,7 @@
           <a:p>
             <a:fld id="{41EA29B2-5B60-4524-9406-F439795E8972}" type="datetimeFigureOut">
               <a:rPr lang="en-US" smtClean="0"/>
-              <a:t>9/28/2026</a:t>
+              <a:t>9/29/2026</a:t>
             </a:fld>
             <a:endParaRPr lang="en-US"/>
           </a:p>
@@ -462,7 +462,7 @@
           <a:p>
             <a:fld id="{41EA29B2-5B60-4524-9406-F439795E8972}" type="datetimeFigureOut">
               <a:rPr lang="en-US" smtClean="0"/>
-              <a:t>9/28/2026</a:t>
+              <a:t>9/29/2026</a:t>
             </a:fld>
             <a:endParaRPr lang="en-US"/>
           </a:p>
@@ -670,7 +670,7 @@
           <a:p>
             <a:fld id="{41EA29B2-5B60-4524-9406-F439795E8972}" type="datetimeFigureOut">
               <a:rPr lang="en-US" smtClean="0"/>
-              <a:t>9/28/2026</a:t>
+              <a:t>9/29/2026</a:t>
             </a:fld>
             <a:endParaRPr lang="en-US"/>
           </a:p>
@@ -868,7 +868,7 @@
           <a:p>
             <a:fld id="{41EA29B2-5B60-4524-9406-F439795E8972}" type="datetimeFigureOut">
               <a:rPr lang="en-US" smtClean="0"/>
-              <a:t>9/28/2026</a:t>
+              <a:t>9/29/2026</a:t>
             </a:fld>
             <a:endParaRPr lang="en-US"/>
           </a:p>
@@ -1143,7 +1143,7 @@
           <a:p>
             <a:fld id="{41EA29B2-5B60-4524-9406-F439795E8972}" type="datetimeFigureOut">
               <a:rPr lang="en-US" smtClean="0"/>
-              <a:t>9/28/2026</a:t>
+              <a:t>9/29/2026</a:t>
             </a:fld>
             <a:endParaRPr lang="en-US"/>
           </a:p>
@@ -1408,7 +1408,7 @@
           <a:p>
             <a:fld id="{41EA29B2-5B60-4524-9406-F439795E8972}" type="datetimeFigureOut">
               <a:rPr lang="en-US" smtClean="0"/>
-              <a:t>9/28/2026</a:t>
+              <a:t>9/29/2026</a:t>
             </a:fld>
             <a:endParaRPr lang="en-US"/>
           </a:p>
@@ -1820,7 +1820,7 @@
           <a:p>
             <a:fld id="{41EA29B2-5B60-4524-9406-F439795E8972}" type="datetimeFigureOut">
               <a:rPr lang="en-US" smtClean="0"/>
-              <a:t>9/28/2026</a:t>
+              <a:t>9/29/2026</a:t>
             </a:fld>
             <a:endParaRPr lang="en-US"/>
           </a:p>
@@ -1961,7 +1961,7 @@
           <a:p>
             <a:fld id="{41EA29B2-5B60-4524-9406-F439795E8972}" type="datetimeFigureOut">
               <a:rPr lang="en-US" smtClean="0"/>
-              <a:t>9/28/2026</a:t>
+              <a:t>9/29/2026</a:t>
             </a:fld>
             <a:endParaRPr lang="en-US"/>
           </a:p>
@@ -2074,7 +2074,7 @@
           <a:p>
             <a:fld id="{41EA29B2-5B60-4524-9406-F439795E8972}" type="datetimeFigureOut">
               <a:rPr lang="en-US" smtClean="0"/>
-              <a:t>9/28/2026</a:t>
+              <a:t>9/29/2026</a:t>
             </a:fld>
             <a:endParaRPr lang="en-US"/>
           </a:p>
@@ -2385,7 +2385,7 @@
           <a:p>
             <a:fld id="{41EA29B2-5B60-4524-9406-F439795E8972}" type="datetimeFigureOut">
               <a:rPr lang="en-US" smtClean="0"/>
-              <a:t>9/28/2026</a:t>
+              <a:t>9/29/2026</a:t>
             </a:fld>
             <a:endParaRPr lang="en-US"/>
           </a:p>
@@ -2673,7 +2673,7 @@
           <a:p>
             <a:fld id="{41EA29B2-5B60-4524-9406-F439795E8972}" type="datetimeFigureOut">
               <a:rPr lang="en-US" smtClean="0"/>
-              <a:t>9/28/2026</a:t>
+              <a:t>9/29/2026</a:t>
             </a:fld>
             <a:endParaRPr lang="en-US"/>
           </a:p>
@@ -2914,7 +2914,7 @@
           <a:p>
             <a:fld id="{41EA29B2-5B60-4524-9406-F439795E8972}" type="datetimeFigureOut">
               <a:rPr lang="en-US" smtClean="0"/>
-              <a:t>9/28/2026</a:t>
+              <a:t>9/29/2026</a:t>
             </a:fld>
             <a:endParaRPr lang="en-US"/>
           </a:p>
@@ -3604,7 +3604,7 @@
         </p:spPr>
         <p:txBody>
           <a:bodyPr>
-            <a:normAutofit lnSpcReduction="10000"/>
+            <a:normAutofit fontScale="92500" lnSpcReduction="20000"/>
           </a:bodyPr>
           <a:lstStyle/>
           <a:p>
@@ -3696,6 +3696,12 @@
             <a:r>
               <a:rPr lang="en-US" dirty="0"/>
               <a:t>Please see Assignments tab in Canvas for specific grading criteria </a:t>
+            </a:r>
+          </a:p>
+          <a:p>
+            <a:r>
+              <a:rPr lang="en-US" dirty="0"/>
+              <a:t>Example proposals and reports can be found under the Modules tab in Canvas</a:t>
             </a:r>
           </a:p>
         </p:txBody>
@@ -4100,6 +4106,55 @@
                       </p:childTnLst>
                     </p:cTn>
                   </p:par>
+                  <p:par>
+                    <p:cTn id="31" fill="hold">
+                      <p:stCondLst>
+                        <p:cond delay="indefinite"/>
+                      </p:stCondLst>
+                      <p:childTnLst>
+                        <p:par>
+                          <p:cTn id="32" fill="hold">
+                            <p:stCondLst>
+                              <p:cond delay="0"/>
+                            </p:stCondLst>
+                            <p:childTnLst>
+                              <p:par>
+                                <p:cTn id="33" presetID="1" presetClass="entr" presetSubtype="0" fill="hold" nodeType="clickEffect">
+                                  <p:stCondLst>
+                                    <p:cond delay="0"/>
+                                  </p:stCondLst>
+                                  <p:childTnLst>
+                                    <p:set>
+                                      <p:cBhvr>
+                                        <p:cTn id="34" dur="1" fill="hold">
+                                          <p:stCondLst>
+                                            <p:cond delay="0"/>
+                                          </p:stCondLst>
+                                        </p:cTn>
+                                        <p:tgtEl>
+                                          <p:spTgt spid="3">
+                                            <p:txEl>
+                                              <p:pRg st="11" end="11"/>
+                                            </p:txEl>
+                                          </p:spTgt>
+                                        </p:tgtEl>
+                                        <p:attrNameLst>
+                                          <p:attrName>style.visibility</p:attrName>
+                                        </p:attrNameLst>
+                                      </p:cBhvr>
+                                      <p:to>
+                                        <p:strVal val="visible"/>
+                                      </p:to>
+                                    </p:set>
+                                  </p:childTnLst>
+                                </p:cTn>
+                              </p:par>
+                            </p:childTnLst>
+                          </p:cTn>
+                        </p:par>
+                      </p:childTnLst>
+                    </p:cTn>
+                  </p:par>
                 </p:childTnLst>
               </p:cTn>
               <p:prevCondLst>
@@ -4218,7 +4273,7 @@
           <a:p>
             <a:r>
               <a:rPr lang="en-US" dirty="0"/>
-              <a:t>Must be focused on data mining methods and algorithms </a:t>
+              <a:t>Must be focused on inference</a:t>
             </a:r>
           </a:p>
           <a:p>
@@ -4236,7 +4291,7 @@
             </a:r>
             <a:r>
               <a:rPr lang="en-US" b="1" dirty="0"/>
-              <a:t>focus on similarity search and unsupervised learning methods</a:t>
+              <a:t>focus on inference and discovery</a:t>
             </a:r>
           </a:p>
           <a:p>
@@ -4916,33 +4971,15 @@
                                   </p:childTnLst>
                                 </p:cTn>
                               </p:par>
-                            </p:childTnLst>
-                          </p:cTn>
-                        </p:par>
-                      </p:childTnLst>
-                    </p:cTn>
-                  </p:par>
-                  <p:par>
-                    <p:cTn id="7" fill="hold">
-                      <p:stCondLst>
-                        <p:cond delay="indefinite"/>
-                      </p:stCondLst>
-                      <p:childTnLst>
-                        <p:par>
-                          <p:cTn id="8" fill="hold">
-                            <p:stCondLst>
-                              <p:cond delay="0"/>
-                            </p:stCondLst>
-                            <p:childTnLst>
                               <p:par>
-                                <p:cTn id="9" presetID="1" presetClass="entr" presetSubtype="0" fill="hold" nodeType="clickEffect">
+                                <p:cTn id="7" presetID="1" presetClass="entr" presetSubtype="0" fill="hold" nodeType="withEffect">
                                   <p:stCondLst>
                                     <p:cond delay="0"/>
                                   </p:stCondLst>
                                   <p:childTnLst>
                                     <p:set>
                                       <p:cBhvr>
-                                        <p:cTn id="10" dur="1" fill="hold">
+                                        <p:cTn id="8" dur="1" fill="hold">
                                           <p:stCondLst>
                                             <p:cond delay="0"/>
                                           </p:stCondLst>
@@ -4965,26 +5002,70 @@
                                   </p:childTnLst>
                                 </p:cTn>
                               </p:par>
-                            </p:childTnLst>
-                          </p:cTn>
-                        </p:par>
-                      </p:childTnLst>
-                    </p:cTn>
-                  </p:par>
-                  <p:par>
-                    <p:cTn id="11" fill="hold">
-                      <p:stCondLst>
-                        <p:cond delay="indefinite"/>
-                      </p:stCondLst>
-                      <p:childTnLst>
-                        <p:par>
-                          <p:cTn id="12" fill="hold">
-                            <p:stCondLst>
-                              <p:cond delay="0"/>
-                            </p:stCondLst>
-                            <p:childTnLst>
                               <p:par>
-                                <p:cTn id="13" presetID="1" presetClass="entr" presetSubtype="0" fill="hold" nodeType="clickEffect">
+                                <p:cTn id="9" presetID="1" presetClass="entr" presetSubtype="0" fill="hold" nodeType="withEffect">
+                                  <p:stCondLst>
+                                    <p:cond delay="0"/>
+                                  </p:stCondLst>
+                                  <p:childTnLst>
+                                    <p:set>
+                                      <p:cBhvr>
+                                        <p:cTn id="10" dur="1" fill="hold">
+                                          <p:stCondLst>
+                                            <p:cond delay="0"/>
+                                          </p:stCondLst>
+                                        </p:cTn>
+                                        <p:tgtEl>
+                                          <p:spTgt spid="3">
+                                            <p:txEl>
+                                              <p:pRg st="4" end="4"/>
+                                            </p:txEl>
+                                          </p:spTgt>
+                                        </p:tgtEl>
+                                        <p:attrNameLst>
+                                          <p:attrName>style.visibility</p:attrName>
+                                        </p:attrNameLst>
+                                      </p:cBhvr>
+                                      <p:to>
+                                        <p:strVal val="visible"/>
+                                      </p:to>
+                                    </p:set>
+                                  </p:childTnLst>
+                                </p:cTn>
+                              </p:par>
+                              <p:par>
+                                <p:cTn id="11" presetID="1" presetClass="entr" presetSubtype="0" fill="hold" nodeType="withEffect">
+                                  <p:stCondLst>
+                                    <p:cond delay="0"/>
+                                  </p:stCondLst>
+                                  <p:childTnLst>
+                                    <p:set>
+                                      <p:cBhvr>
+                                        <p:cTn id="12" dur="1" fill="hold">
+                                          <p:stCondLst>
+                                            <p:cond delay="0"/>
+                                          </p:stCondLst>
+                                        </p:cTn>
+                                        <p:tgtEl>
+                                          <p:spTgt spid="3">
+                                            <p:txEl>
+                                              <p:pRg st="2" end="2"/>
+                                            </p:txEl>
+                                          </p:spTgt>
+                                        </p:tgtEl>
+                                        <p:attrNameLst>
+                                          <p:attrName>style.visibility</p:attrName>
+                                        </p:attrNameLst>
+                                      </p:cBhvr>
+                                      <p:to>
+                                        <p:strVal val="visible"/>
+                                      </p:to>
+                                    </p:set>
+                                  </p:childTnLst>
+                                </p:cTn>
+                              </p:par>
+                              <p:par>
+                                <p:cTn id="13" presetID="1" presetClass="entr" presetSubtype="0" fill="hold" nodeType="withEffect">
                                   <p:stCondLst>
                                     <p:cond delay="0"/>
                                   </p:stCondLst>
@@ -4999,7 +5080,7 @@
                                         <p:tgtEl>
                                           <p:spTgt spid="3">
                                             <p:txEl>
-                                              <p:pRg st="4" end="4"/>
+                                              <p:pRg st="5" end="5"/>
                                             </p:txEl>
                                           </p:spTgt>
                                         </p:tgtEl>
@@ -5048,7 +5129,7 @@
                                         <p:tgtEl>
                                           <p:spTgt spid="3">
                                             <p:txEl>
-                                              <p:pRg st="2" end="2"/>
+                                              <p:pRg st="6" end="6"/>
                                             </p:txEl>
                                           </p:spTgt>
                                         </p:tgtEl>
@@ -5079,7 +5160,7 @@
                                         <p:tgtEl>
                                           <p:spTgt spid="3">
                                             <p:txEl>
-                                              <p:pRg st="5" end="5"/>
+                                              <p:pRg st="7" end="7"/>
                                             </p:txEl>
                                           </p:spTgt>
                                         </p:tgtEl>
@@ -5094,26 +5175,39 @@
                                   </p:childTnLst>
                                 </p:cTn>
                               </p:par>
-                            </p:childTnLst>
-                          </p:cTn>
-                        </p:par>
-                      </p:childTnLst>
-                    </p:cTn>
-                  </p:par>
-                  <p:par>
-                    <p:cTn id="21" fill="hold">
-                      <p:stCondLst>
-                        <p:cond delay="indefinite"/>
-                      </p:stCondLst>
-                      <p:childTnLst>
-                        <p:par>
-                          <p:cTn id="22" fill="hold">
-                            <p:stCondLst>
-                              <p:cond delay="0"/>
-                            </p:stCondLst>
-                            <p:childTnLst>
                               <p:par>
-                                <p:cTn id="23" presetID="1" presetClass="entr" presetSubtype="0" fill="hold" nodeType="clickEffect">
+                                <p:cTn id="21" presetID="1" presetClass="entr" presetSubtype="0" fill="hold" nodeType="withEffect">
+                                  <p:stCondLst>
+                                    <p:cond delay="0"/>
+                                  </p:stCondLst>
+                                  <p:childTnLst>
+                                    <p:set>
+                                      <p:cBhvr>
+                                        <p:cTn id="22" dur="1" fill="hold">
+                                          <p:stCondLst>
+                                            <p:cond delay="0"/>
+                                          </p:stCondLst>
+                                        </p:cTn>
+                                        <p:tgtEl>
+                                          <p:spTgt spid="3">
+                                            <p:txEl>
+                                              <p:pRg st="8" end="8"/>
+                                            </p:txEl>
+                                          </p:spTgt>
+                                        </p:tgtEl>
+                                        <p:attrNameLst>
+                                          <p:attrName>style.visibility</p:attrName>
+                                        </p:attrNameLst>
+                                      </p:cBhvr>
+                                      <p:to>
+                                        <p:strVal val="visible"/>
+                                      </p:to>
+                                    </p:set>
+                                  </p:childTnLst>
+                                </p:cTn>
+                              </p:par>
+                              <p:par>
+                                <p:cTn id="23" presetID="1" presetClass="entr" presetSubtype="0" fill="hold" nodeType="withEffect">
                                   <p:stCondLst>
                                     <p:cond delay="0"/>
                                   </p:stCondLst>
@@ -5128,7 +5222,7 @@
                                         <p:tgtEl>
                                           <p:spTgt spid="3">
                                             <p:txEl>
-                                              <p:pRg st="6" end="6"/>
+                                              <p:pRg st="9" end="9"/>
                                             </p:txEl>
                                           </p:spTgt>
                                         </p:tgtEl>
@@ -5152,99 +5246,6 @@
                                     <p:set>
                                       <p:cBhvr>
                                         <p:cTn id="26" dur="1" fill="hold">
-                                          <p:stCondLst>
-                                            <p:cond delay="0"/>
-                                          </p:stCondLst>
-                                        </p:cTn>
-                                        <p:tgtEl>
-                                          <p:spTgt spid="3">
-                                            <p:txEl>
-                                              <p:pRg st="7" end="7"/>
-                                            </p:txEl>
-                                          </p:spTgt>
-                                        </p:tgtEl>
-                                        <p:attrNameLst>
-                                          <p:attrName>style.visibility</p:attrName>
-                                        </p:attrNameLst>
-                                      </p:cBhvr>
-                                      <p:to>
-                                        <p:strVal val="visible"/>
-                                      </p:to>
-                                    </p:set>
-                                  </p:childTnLst>
-                                </p:cTn>
-                              </p:par>
-                              <p:par>
-                                <p:cTn id="27" presetID="1" presetClass="entr" presetSubtype="0" fill="hold" nodeType="withEffect">
-                                  <p:stCondLst>
-                                    <p:cond delay="0"/>
-                                  </p:stCondLst>
-                                  <p:childTnLst>
-                                    <p:set>
-                                      <p:cBhvr>
-                                        <p:cTn id="28" dur="1" fill="hold">
-                                          <p:stCondLst>
-                                            <p:cond delay="0"/>
-                                          </p:stCondLst>
-                                        </p:cTn>
-                                        <p:tgtEl>
-                                          <p:spTgt spid="3">
-                                            <p:txEl>
-                                              <p:pRg st="8" end="8"/>
-                                            </p:txEl>
-                                          </p:spTgt>
-                                        </p:tgtEl>
-                                        <p:attrNameLst>
-                                          <p:attrName>style.visibility</p:attrName>
-                                        </p:attrNameLst>
-                                      </p:cBhvr>
-                                      <p:to>
-                                        <p:strVal val="visible"/>
-                                      </p:to>
-                                    </p:set>
-                                  </p:childTnLst>
-                                </p:cTn>
-                              </p:par>
-                              <p:par>
-                                <p:cTn id="29" presetID="1" presetClass="entr" presetSubtype="0" fill="hold" nodeType="withEffect">
-                                  <p:stCondLst>
-                                    <p:cond delay="0"/>
-                                  </p:stCondLst>
-                                  <p:childTnLst>
-                                    <p:set>
-                                      <p:cBhvr>
-                                        <p:cTn id="30" dur="1" fill="hold">
-                                          <p:stCondLst>
-                                            <p:cond delay="0"/>
-                                          </p:stCondLst>
-                                        </p:cTn>
-                                        <p:tgtEl>
-                                          <p:spTgt spid="3">
-                                            <p:txEl>
-                                              <p:pRg st="9" end="9"/>
-                                            </p:txEl>
-                                          </p:spTgt>
-                                        </p:tgtEl>
-                                        <p:attrNameLst>
-                                          <p:attrName>style.visibility</p:attrName>
-                                        </p:attrNameLst>
-                                      </p:cBhvr>
-                                      <p:to>
-                                        <p:strVal val="visible"/>
-                                      </p:to>
-                                    </p:set>
-                                  </p:childTnLst>
-                                </p:cTn>
-                              </p:par>
-                              <p:par>
-                                <p:cTn id="31" presetID="1" presetClass="entr" presetSubtype="0" fill="hold" nodeType="withEffect">
-                                  <p:stCondLst>
-                                    <p:cond delay="0"/>
-                                  </p:stCondLst>
-                                  <p:childTnLst>
-                                    <p:set>
-                                      <p:cBhvr>
-                                        <p:cTn id="32" dur="1" fill="hold">
                                           <p:stCondLst>
                                             <p:cond delay="0"/>
                                           </p:stCondLst>
@@ -5385,13 +5386,13 @@
             </a:pPr>
             <a:r>
               <a:rPr lang="en-US" b="1" dirty="0"/>
-              <a:t>Project proposal helps ensure your project have:</a:t>
+              <a:t>Project proposal helps ensure your project has:</a:t>
             </a:r>
           </a:p>
           <a:p>
             <a:r>
               <a:rPr lang="en-US" dirty="0"/>
-              <a:t>Clear and reasonable data mining objective</a:t>
+              <a:t>Clear and reasonable inference and discovery objective</a:t>
             </a:r>
           </a:p>
           <a:p>
@@ -5463,7 +5464,7 @@
           <a:p>
             <a:r>
               <a:rPr lang="en-US" dirty="0"/>
-              <a:t>Use appropriate data mining methods</a:t>
+              <a:t>Use appropriate inference methods</a:t>
             </a:r>
           </a:p>
           <a:p>
@@ -6099,7 +6100,15 @@
             </a:pPr>
             <a:r>
               <a:rPr lang="en-US" b="1" dirty="0"/>
-              <a:t>Project report must:</a:t>
+              <a:t>Project report in one </a:t>
+            </a:r>
+            <a:r>
+              <a:rPr lang="en-US" b="1"/>
+              <a:t>Jupyter notebook </a:t>
+            </a:r>
+            <a:r>
+              <a:rPr lang="en-US" b="1" dirty="0"/>
+              <a:t>must:</a:t>
             </a:r>
           </a:p>
           <a:p>
@@ -6123,7 +6132,7 @@
           <a:p>
             <a:r>
               <a:rPr lang="en-US" dirty="0"/>
-              <a:t>Support conclusions and discoveries based on evidence gathered in the data mining process</a:t>
+              <a:t>Support conclusions and discoveries based on evidence gathered from the inferences</a:t>
             </a:r>
           </a:p>
           <a:p>
@@ -6184,13 +6193,8 @@
             </a:r>
             <a:r>
               <a:rPr lang="en-US" b="1" dirty="0"/>
-              <a:t>enhancing methods or using </a:t>
-            </a:r>
-            <a:r>
-              <a:rPr lang="en-US" b="1"/>
-              <a:t>other methods</a:t>
-            </a:r>
-            <a:endParaRPr lang="en-US" b="1" dirty="0"/>
+              <a:t>enhancing methods or using other methods</a:t>
+            </a:r>
           </a:p>
           <a:p>
             <a:r>

</xml_diff>